<commit_message>
Final stretch: use the idiomatic hardware2 recording; correct all deck/doc numbers
- fixtures/cassettes/hardware.json is now the cleaner rerun (recorded with
  the arch-templating + ANSI fixes in place): same SUCCESS / 3 iterations,
  but the agent produced the idiomatic HIP CMake port (find_package(hip),
  hip::device) — a sharper artifact that also matches the pod screenshots
  used in the video. Replays exactly: SUCCESS, 3 iters, $0.0456.
- Regenerated pitch/bridge_pitch.pptx from an updated build_deck.js: 135
  tests (was 119), Gemma slide now reports the real comparison (Gemma 4,
  3/7, plus the <thought>-stripping fix it forced), the AMD-stack slide
  marks the Radeon hardware run DONE (not MI300X-next), and the roadmap
  keeps MI300X as the genuine next step. Verified no stale strings remain.
- README hardware row, video script, demo page, hardware_runbook, and
  deck_delta all updated to ~$0.05 and 135 tests to match the shipped
  recording. 135 tests green.
</commit_message>
<xml_diff>
--- a/pitch/bridge_pitch.pptx
+++ b/pitch/bridge_pitch.pptx
@@ -5632,7 +5632,7 @@
                 <a:ea typeface="Arial" pitchFamily="34" charset="-122"/>
                 <a:cs typeface="Arial" pitchFamily="34" charset="-120"/>
               </a:rPr>
-              <a:t>119 tests · CI green</a:t>
+              <a:t>135 tests · CI green</a:t>
             </a:r>
             <a:endParaRPr lang="en-US" sz="1650" dirty="0"/>
           </a:p>
@@ -7198,7 +7198,7 @@
                 <a:ea typeface="Courier New" pitchFamily="34" charset="-122"/>
                 <a:cs typeface="Courier New" pitchFamily="34" charset="-120"/>
               </a:rPr>
-              <a:t>accounts/fireworks/models/gemma-3-27b-it</a:t>
+              <a:t>accounts/fireworks/models/gemma-4-31b-it</a:t>
             </a:r>
             <a:endParaRPr lang="en-US" sz="1600" dirty="0"/>
           </a:p>
@@ -7271,7 +7271,7 @@
                 <a:ea typeface="Arial" pitchFamily="34" charset="-122"/>
                 <a:cs typeface="Arial" pitchFamily="34" charset="-120"/>
               </a:rPr>
-              <a:t>Enters the Gemma challenge</a:t>
+              <a:t>We ran the comparison</a:t>
             </a:r>
             <a:endParaRPr lang="en-US" sz="1650" dirty="0"/>
           </a:p>
@@ -7313,7 +7313,7 @@
                 <a:ea typeface="Calibri" pitchFamily="34" charset="-122"/>
                 <a:cs typeface="Calibri" pitchFamily="34" charset="-120"/>
               </a:rPr>
-              <a:t>The same agent, driven by Google's Gemma — a one-file config, no code change. Recorded as an honest model-vs-model comparison run.</a:t>
+              <a:t>Gemma 4 31B fixed 3 of 7 error classes on the same migration Kimi aced — honest numbers, recorded, and the safety gate held identically for both brains.</a:t>
             </a:r>
             <a:endParaRPr lang="en-US" sz="1300" dirty="0"/>
           </a:p>
@@ -7386,7 +7386,7 @@
                 <a:ea typeface="Arial" pitchFamily="34" charset="-122"/>
                 <a:cs typeface="Arial" pitchFamily="34" charset="-120"/>
               </a:rPr>
-              <a:t>Gemma, thinking on AMD</a:t>
+              <a:t>It hardened the agent</a:t>
             </a:r>
             <a:endParaRPr lang="en-US" sz="1650" dirty="0"/>
           </a:p>
@@ -7428,7 +7428,7 @@
                 <a:ea typeface="Calibri" pitchFamily="34" charset="-122"/>
                 <a:cs typeface="Calibri" pitchFamily="34" charset="-120"/>
               </a:rPr>
-              <a:t>The endpoint is just OpenAI-compatible, so Gemma can be self-hosted on the MI300X via vLLM — the brain running on AMD while it ports code to AMD.</a:t>
+              <a:t>Gemma 4's &lt;thought&gt; markup broke diff extraction; Bridge's output parser now strips it, test-pinned. The gate is model-independent.</a:t>
             </a:r>
             <a:endParaRPr lang="en-US" sz="1300" dirty="0"/>
           </a:p>
@@ -7854,7 +7854,7 @@
                 <a:ea typeface="Calibri" pitchFamily="34" charset="-122"/>
                 <a:cs typeface="Calibri" pitchFamily="34" charset="-120"/>
               </a:rPr>
-              <a:t>The whole point: CUDA → HIP so it builds on Instinct.</a:t>
+              <a:t>The whole point: CUDA → HIP so it builds on AMD GPUs.</a:t>
             </a:r>
             <a:endParaRPr lang="en-US" sz="1300" dirty="0"/>
           </a:p>
@@ -8343,7 +8343,7 @@
                 <a:ea typeface="Arial" pitchFamily="34" charset="-122"/>
                 <a:cs typeface="Arial" pitchFamily="34" charset="-120"/>
               </a:rPr>
-              <a:t>Gemma one-line swap</a:t>
+              <a:t>Gemma comparison run</a:t>
             </a:r>
             <a:endParaRPr lang="en-US" sz="1550" dirty="0"/>
           </a:p>
@@ -8382,7 +8382,7 @@
                 <a:ea typeface="Calibri" pitchFamily="34" charset="-122"/>
                 <a:cs typeface="Calibri" pitchFamily="34" charset="-120"/>
               </a:rPr>
-              <a:t>Model-agnostic; enters the Gemma challenge.</a:t>
+              <a:t>Model-agnostic; the recorded Gemma 4 entry, 3 of 7.</a:t>
             </a:r>
             <a:endParaRPr lang="en-US" sz="1300" dirty="0"/>
           </a:p>
@@ -8437,11 +8437,11 @@
             <a:avLst/>
           </a:prstGeom>
           <a:solidFill>
-            <a:srgbClr val="2E2410"/>
+            <a:srgbClr val="0E2A1E"/>
           </a:solidFill>
           <a:ln w="12700">
             <a:solidFill>
-              <a:srgbClr val="F2B441"/>
+              <a:srgbClr val="35D08A"/>
             </a:solidFill>
             <a:prstDash val="solid"/>
           </a:ln>
@@ -8474,13 +8474,13 @@
             <a:r>
               <a:rPr lang="en-US" sz="1500" b="1" dirty="0">
                 <a:solidFill>
-                  <a:srgbClr val="F2B441"/>
+                  <a:srgbClr val="35D08A"/>
                 </a:solidFill>
                 <a:latin typeface="Arial" pitchFamily="34" charset="0"/>
                 <a:ea typeface="Arial" pitchFamily="34" charset="-122"/>
                 <a:cs typeface="Arial" pitchFamily="34" charset="-120"/>
               </a:rPr>
-              <a:t>→</a:t>
+              <a:t>✓</a:t>
             </a:r>
             <a:endParaRPr lang="en-US" sz="1500" dirty="0"/>
           </a:p>
@@ -8519,7 +8519,7 @@
                 <a:ea typeface="Arial" pitchFamily="34" charset="-122"/>
                 <a:cs typeface="Arial" pitchFamily="34" charset="-120"/>
               </a:rPr>
-              <a:t>MI300X on AMD Dev Cloud</a:t>
+              <a:t>Ran on AMD hardware</a:t>
             </a:r>
             <a:endParaRPr lang="en-US" sz="1550" dirty="0"/>
           </a:p>
@@ -8558,7 +8558,7 @@
                 <a:ea typeface="Calibri" pitchFamily="34" charset="-122"/>
                 <a:cs typeface="Calibri" pitchFamily="34" charset="-120"/>
               </a:rPr>
-              <a:t>Live on-hardware migration — tooling ready, runs on approval.</a:t>
+              <a:t>Autonomous port on a Radeon GPU (gfx1100), ctest 100%.</a:t>
             </a:r>
             <a:endParaRPr lang="en-US" sz="1300" dirty="0"/>
           </a:p>
@@ -8567,45 +8567,6 @@
       <p:sp>
         <p:nvSpPr>
           <p:cNvPr id="30" name="Text 28"/>
-          <p:cNvSpPr/>
-          <p:nvPr/>
-        </p:nvSpPr>
-        <p:spPr>
-          <a:xfrm>
-            <a:off x="10561320" y="6108192"/>
-            <a:ext cx="777240" cy="365760"/>
-          </a:xfrm>
-          <a:prstGeom prst="rect">
-            <a:avLst/>
-          </a:prstGeom>
-          <a:noFill/>
-          <a:ln/>
-        </p:spPr>
-        <p:txBody>
-          <a:bodyPr wrap="square" lIns="0" tIns="0" rIns="0" bIns="0" rtlCol="0" anchor="ctr"/>
-          <a:lstStyle/>
-          <a:p>
-            <a:pPr algn="ctr" indent="0" marL="0">
-              <a:buNone/>
-            </a:pPr>
-            <a:r>
-              <a:rPr lang="en-US" sz="1100" b="1" dirty="0">
-                <a:solidFill>
-                  <a:srgbClr val="F2B441"/>
-                </a:solidFill>
-                <a:latin typeface="Arial" pitchFamily="34" charset="0"/>
-                <a:ea typeface="Arial" pitchFamily="34" charset="-122"/>
-                <a:cs typeface="Arial" pitchFamily="34" charset="-120"/>
-              </a:rPr>
-              <a:t>NEXT</a:t>
-            </a:r>
-            <a:endParaRPr lang="en-US" sz="1100" dirty="0"/>
-          </a:p>
-        </p:txBody>
-      </p:sp>
-      <p:sp>
-        <p:nvSpPr>
-          <p:cNvPr id="31" name="Text 29"/>
           <p:cNvSpPr/>
           <p:nvPr/>
         </p:nvSpPr>
@@ -8644,7 +8605,7 @@
       </p:sp>
       <p:sp>
         <p:nvSpPr>
-          <p:cNvPr id="32" name="Text 30"/>
+          <p:cNvPr id="31" name="Text 29"/>
           <p:cNvSpPr/>
           <p:nvPr/>
         </p:nvSpPr>
@@ -8965,7 +8926,7 @@
                 <a:ea typeface="Calibri" pitchFamily="34" charset="-122"/>
                 <a:cs typeface="Calibri" pitchFamily="34" charset="-120"/>
               </a:rPr>
-              <a:t>Live dashboard (real diffs &amp; cost)</a:t>
+              <a:t>135 tests green · GitHub Actions CI</a:t>
             </a:r>
             <a:endParaRPr lang="en-US" sz="1400" dirty="0"/>
           </a:p>
@@ -8986,7 +8947,7 @@
                 <a:ea typeface="Calibri" pitchFamily="34" charset="-122"/>
                 <a:cs typeface="Calibri" pitchFamily="34" charset="-120"/>
               </a:rPr>
-              <a:t>119 tests green · GitHub Actions CI</a:t>
+              <a:t>Live Fireworks run → SUCCESS (7/7)</a:t>
             </a:r>
             <a:endParaRPr lang="en-US" sz="1400" dirty="0"/>
           </a:p>
@@ -9007,7 +8968,7 @@
                 <a:ea typeface="Calibri" pitchFamily="34" charset="-122"/>
                 <a:cs typeface="Calibri" pitchFamily="34" charset="-120"/>
               </a:rPr>
-              <a:t>docker compose up demo, offline</a:t>
+              <a:t>Autonomous port on AMD hardware (gfx1100)</a:t>
             </a:r>
             <a:endParaRPr lang="en-US" sz="1400" dirty="0"/>
           </a:p>
@@ -9028,7 +8989,7 @@
                 <a:ea typeface="Calibri" pitchFamily="34" charset="-122"/>
                 <a:cs typeface="Calibri" pitchFamily="34" charset="-120"/>
               </a:rPr>
-              <a:t>Live Fireworks run → SUCCESS</a:t>
+              <a:t>docker compose up demo, offline</a:t>
             </a:r>
             <a:endParaRPr lang="en-US" sz="1400" dirty="0"/>
           </a:p>
@@ -9185,7 +9146,7 @@
                 <a:ea typeface="Calibri" pitchFamily="34" charset="-122"/>
                 <a:cs typeface="Calibri" pitchFamily="34" charset="-120"/>
               </a:rPr>
-              <a:t>Live migration on a real MI300X</a:t>
+              <a:t>The same run on a real MI300X</a:t>
             </a:r>
             <a:endParaRPr lang="en-US" sz="1400" dirty="0"/>
           </a:p>
@@ -9227,7 +9188,7 @@
                 <a:ea typeface="Calibri" pitchFamily="34" charset="-122"/>
                 <a:cs typeface="Calibri" pitchFamily="34" charset="-120"/>
               </a:rPr>
-              <a:t>Repo-shortlist on hardware, pick demo</a:t>
+              <a:t>Sandbox + hash-chained audit log</a:t>
             </a:r>
             <a:endParaRPr lang="en-US" sz="1400" dirty="0"/>
           </a:p>
@@ -9248,7 +9209,7 @@
                 <a:ea typeface="Calibri" pitchFamily="34" charset="-122"/>
                 <a:cs typeface="Calibri" pitchFamily="34" charset="-120"/>
               </a:rPr>
-              <a:t>Recorded Gemma comparison run</a:t>
+              <a:t>A corpus of real CUDA repos</a:t>
             </a:r>
             <a:endParaRPr lang="en-US" sz="1400" dirty="0"/>
           </a:p>
@@ -9290,7 +9251,7 @@
                 <a:ea typeface="Calibri" pitchFamily="34" charset="-122"/>
                 <a:cs typeface="Calibri" pitchFamily="34" charset="-120"/>
               </a:rPr>
-              <a:t>Every hardware step has tooling written and waiting — it runs the moment the MI300X is provisioned.</a:t>
+              <a:t>Ported on a Radeon today; the MI300X is a one-line arch swap away.</a:t>
             </a:r>
             <a:endParaRPr lang="en-US" sz="1150" dirty="0"/>
           </a:p>

</xml_diff>